<commit_message>
Ads MVP functionality. tests for simulation
</commit_message>
<xml_diff>
--- a/Präsentation_Refactoring/Softwarearchäologie live.pptx
+++ b/Präsentation_Refactoring/Softwarearchäologie live.pptx
@@ -5,7 +5,7 @@
     <p:sldMasterId id="2147483829" r:id="rId6"/>
   </p:sldMasterIdLst>
   <p:notesMasterIdLst>
-    <p:notesMasterId r:id="rId27"/>
+    <p:notesMasterId r:id="rId29"/>
   </p:notesMasterIdLst>
   <p:sldIdLst>
     <p:sldId id="256" r:id="rId7"/>
@@ -28,6 +28,8 @@
     <p:sldId id="274" r:id="rId24"/>
     <p:sldId id="275" r:id="rId25"/>
     <p:sldId id="276" r:id="rId26"/>
+    <p:sldId id="277" r:id="rId27"/>
+    <p:sldId id="278" r:id="rId28"/>
   </p:sldIdLst>
   <p:sldSz cx="12192000" cy="6858000"/>
   <p:notesSz cx="6858000" cy="9144000"/>
@@ -181,6 +183,8 @@
             <p14:sldId id="274"/>
             <p14:sldId id="275"/>
             <p14:sldId id="276"/>
+            <p14:sldId id="277"/>
+            <p14:sldId id="278"/>
           </p14:sldIdLst>
         </p14:section>
       </p14:sectionLst>
@@ -33340,15 +33344,145 @@
             </a:r>
             <a:r>
               <a:rPr lang="de-DE" dirty="0"/>
-              <a:t>, es läuft </a:t>
-            </a:r>
-            <a:r>
-              <a:rPr lang="de-DE"/>
-              <a:t>auf anhieb.</a:t>
-            </a:r>
-          </a:p>
-          <a:p>
-            <a:endParaRPr lang="de-DE"/>
+              <a:t>, es läuft auf anhieb.</a:t>
+            </a:r>
+          </a:p>
+          <a:p>
+            <a:r>
+              <a:rPr lang="de-DE" dirty="0"/>
+              <a:t>Mein Gehirn plant zu langsam / zu kleinschrittig.</a:t>
+            </a:r>
+          </a:p>
+          <a:p>
+            <a:pPr lvl="1"/>
+            <a:r>
+              <a:rPr lang="de-DE" dirty="0"/>
+              <a:t>Was will ich denn als nächstes machen? Wo ist mein Big Picture / großer Plan?</a:t>
+            </a:r>
+          </a:p>
+          <a:p>
+            <a:pPr lvl="1"/>
+            <a:r>
+              <a:rPr lang="de-DE" dirty="0"/>
+              <a:t>KI hat den Plan im Speicher.</a:t>
+            </a:r>
+          </a:p>
+          <a:p>
+            <a:pPr lvl="1"/>
+            <a:r>
+              <a:rPr lang="de-DE" dirty="0"/>
+              <a:t>Nächster Schritt laut KI: </a:t>
+            </a:r>
+            <a:r>
+              <a:rPr lang="de-DE" dirty="0" err="1"/>
+              <a:t>Configuration</a:t>
+            </a:r>
+            <a:r>
+              <a:rPr lang="de-DE" dirty="0"/>
+              <a:t> einbinden</a:t>
+            </a:r>
+          </a:p>
+          <a:p>
+            <a:pPr lvl="1"/>
+            <a:r>
+              <a:rPr lang="de-DE" dirty="0"/>
+              <a:t>Gefühlt hätte ich das auch getan, mir fehlt aber der übernächste Schritt / große Plan zum Endprodukt.</a:t>
+            </a:r>
+          </a:p>
+          <a:p>
+            <a:pPr lvl="1"/>
+            <a:r>
+              <a:rPr lang="de-DE" dirty="0"/>
+              <a:t>Was ist der nächste Meilenstein? Der Ursprünglich erarbeitete </a:t>
+            </a:r>
+            <a:r>
+              <a:rPr lang="de-DE" dirty="0" err="1"/>
+              <a:t>Taskplan</a:t>
+            </a:r>
+            <a:r>
+              <a:rPr lang="de-DE" dirty="0"/>
+              <a:t> hilft nicht wirklich. Laut dem Plan bin ich Anfang November / 2 Monate in der Zukunft. (Hardware-test </a:t>
+            </a:r>
+            <a:r>
+              <a:rPr lang="de-DE" dirty="0" err="1"/>
+              <a:t>fixtures</a:t>
+            </a:r>
+            <a:r>
+              <a:rPr lang="de-DE" dirty="0"/>
+              <a:t> habe ich übersprungen)</a:t>
+            </a:r>
+            <a:br>
+              <a:rPr lang="de-DE" dirty="0"/>
+            </a:br>
+            <a:r>
+              <a:rPr lang="de-DE" dirty="0">
+                <a:sym typeface="Wingdings" panose="05000000000000000000" pitchFamily="2" charset="2"/>
+              </a:rPr>
+              <a:t> Aktueller Task: „</a:t>
+            </a:r>
+            <a:r>
+              <a:rPr lang="de-DE" dirty="0" err="1">
+                <a:sym typeface="Wingdings" panose="05000000000000000000" pitchFamily="2" charset="2"/>
+              </a:rPr>
+              <a:t>Process</a:t>
+            </a:r>
+            <a:r>
+              <a:rPr lang="de-DE" dirty="0">
+                <a:sym typeface="Wingdings" panose="05000000000000000000" pitchFamily="2" charset="2"/>
+              </a:rPr>
+              <a:t>-Control GUI and </a:t>
+            </a:r>
+            <a:r>
+              <a:rPr lang="de-DE" dirty="0" err="1">
+                <a:sym typeface="Wingdings" panose="05000000000000000000" pitchFamily="2" charset="2"/>
+              </a:rPr>
+              <a:t>logging</a:t>
+            </a:r>
+            <a:r>
+              <a:rPr lang="de-DE" dirty="0">
+                <a:sym typeface="Wingdings" panose="05000000000000000000" pitchFamily="2" charset="2"/>
+              </a:rPr>
+              <a:t>“. Nicht falsch, nicht hilfreich.</a:t>
+            </a:r>
+          </a:p>
+          <a:p>
+            <a:pPr lvl="1"/>
+            <a:r>
+              <a:rPr lang="de-DE" dirty="0"/>
+              <a:t>Meilenstein: Ich will </a:t>
+            </a:r>
+            <a:r>
+              <a:rPr lang="de-DE" dirty="0" err="1"/>
+              <a:t>Unittesten</a:t>
+            </a:r>
+            <a:r>
+              <a:rPr lang="de-DE" dirty="0"/>
+              <a:t> können. Auf meinem Windows-Laptop. Also wieder Infrastruktur / .</a:t>
+            </a:r>
+            <a:r>
+              <a:rPr lang="de-DE" dirty="0" err="1"/>
+              <a:t>venv</a:t>
+            </a:r>
+            <a:r>
+              <a:rPr lang="de-DE" dirty="0"/>
+              <a:t> aufsetzen. Oder verzichte ich darauf und arbeite direkt auf dem </a:t>
+            </a:r>
+            <a:r>
+              <a:rPr lang="de-DE" dirty="0" err="1"/>
+              <a:t>pcberry</a:t>
+            </a:r>
+            <a:r>
+              <a:rPr lang="de-DE" dirty="0"/>
+              <a:t>? Fragen und </a:t>
+            </a:r>
+            <a:r>
+              <a:rPr lang="de-DE" dirty="0" err="1"/>
+              <a:t>entscheidungen</a:t>
+            </a:r>
+            <a:r>
+              <a:rPr lang="de-DE" dirty="0"/>
+              <a:t> dauern länger als das eigentliche coden. Gefühl sagt: Wenn ich wüsste, was ich will, wäre ich längst fertig. </a:t>
+            </a:r>
           </a:p>
         </p:txBody>
       </p:sp>
@@ -33443,6 +33577,658 @@
     <p:extLst>
       <p:ext uri="{BB962C8B-B14F-4D97-AF65-F5344CB8AC3E}">
         <p14:creationId xmlns:p14="http://schemas.microsoft.com/office/powerpoint/2010/main" val="2264229981"/>
+      </p:ext>
+    </p:extLst>
+  </p:cSld>
+  <p:clrMapOvr>
+    <a:masterClrMapping/>
+  </p:clrMapOvr>
+</p:sld>
+</file>
+
+<file path=ppt/slides/slide21.xml><?xml version="1.0" encoding="utf-8"?>
+<p:sld xmlns:a="http://schemas.openxmlformats.org/drawingml/2006/main" xmlns:r="http://schemas.openxmlformats.org/officeDocument/2006/relationships" xmlns:p="http://schemas.openxmlformats.org/presentationml/2006/main">
+  <p:cSld>
+    <p:spTree>
+      <p:nvGrpSpPr>
+        <p:cNvPr id="1" name=""/>
+        <p:cNvGrpSpPr/>
+        <p:nvPr/>
+      </p:nvGrpSpPr>
+      <p:grpSpPr>
+        <a:xfrm>
+          <a:off x="0" y="0"/>
+          <a:ext cx="0" cy="0"/>
+          <a:chOff x="0" y="0"/>
+          <a:chExt cx="0" cy="0"/>
+        </a:xfrm>
+      </p:grpSpPr>
+      <p:sp>
+        <p:nvSpPr>
+          <p:cNvPr id="2" name="Fußzeilenplatzhalter 1">
+            <a:extLst>
+              <a:ext uri="{FF2B5EF4-FFF2-40B4-BE49-F238E27FC236}">
+                <a16:creationId xmlns:a16="http://schemas.microsoft.com/office/drawing/2014/main" id="{7764058C-9E81-6067-9C6A-F4A544D1A733}"/>
+              </a:ext>
+            </a:extLst>
+          </p:cNvPr>
+          <p:cNvSpPr>
+            <a:spLocks noGrp="1"/>
+          </p:cNvSpPr>
+          <p:nvPr>
+            <p:ph type="ftr" sz="quarter" idx="3"/>
+          </p:nvPr>
+        </p:nvSpPr>
+        <p:spPr/>
+        <p:txBody>
+          <a:bodyPr/>
+          <a:lstStyle/>
+          <a:p>
+            <a:r>
+              <a:rPr lang="de-DE"/>
+              <a:t>Unternehmensmaster Smart Mechatronics</a:t>
+            </a:r>
+            <a:endParaRPr lang="de-DE" dirty="0"/>
+          </a:p>
+        </p:txBody>
+      </p:sp>
+      <p:sp>
+        <p:nvSpPr>
+          <p:cNvPr id="3" name="Inhaltsplatzhalter 2">
+            <a:extLst>
+              <a:ext uri="{FF2B5EF4-FFF2-40B4-BE49-F238E27FC236}">
+                <a16:creationId xmlns:a16="http://schemas.microsoft.com/office/drawing/2014/main" id="{7C12FEE7-6492-0CB6-0B5A-EC361C024CE6}"/>
+              </a:ext>
+            </a:extLst>
+          </p:cNvPr>
+          <p:cNvSpPr>
+            <a:spLocks noGrp="1"/>
+          </p:cNvSpPr>
+          <p:nvPr>
+            <p:ph idx="1"/>
+          </p:nvPr>
+        </p:nvSpPr>
+        <p:spPr/>
+        <p:txBody>
+          <a:bodyPr/>
+          <a:lstStyle/>
+          <a:p>
+            <a:r>
+              <a:rPr lang="de-DE" dirty="0"/>
+              <a:t>Neue Main-file.</a:t>
+            </a:r>
+          </a:p>
+          <a:p>
+            <a:pPr lvl="1"/>
+            <a:r>
+              <a:rPr lang="de-DE" dirty="0"/>
+              <a:t>Soll Scheduling machen</a:t>
+            </a:r>
+          </a:p>
+          <a:p>
+            <a:pPr lvl="1"/>
+            <a:r>
+              <a:rPr lang="de-DE" dirty="0"/>
+              <a:t>Soll </a:t>
+            </a:r>
+            <a:r>
+              <a:rPr lang="de-DE" dirty="0" err="1"/>
+              <a:t>configuration</a:t>
+            </a:r>
+            <a:r>
+              <a:rPr lang="de-DE" dirty="0"/>
+              <a:t> lesen</a:t>
+            </a:r>
+          </a:p>
+          <a:p>
+            <a:pPr lvl="1"/>
+            <a:r>
+              <a:rPr lang="de-DE" dirty="0"/>
+              <a:t>Soll CAN Kommunikation lesen und </a:t>
+            </a:r>
+            <a:r>
+              <a:rPr lang="de-DE" dirty="0" err="1"/>
+              <a:t>umschaltung</a:t>
+            </a:r>
+            <a:r>
+              <a:rPr lang="de-DE" dirty="0"/>
+              <a:t> zu Dummy Kommunikation beinhalten</a:t>
+            </a:r>
+          </a:p>
+          <a:p>
+            <a:pPr lvl="2"/>
+            <a:r>
+              <a:rPr lang="de-DE" dirty="0"/>
+              <a:t>Dummy Kommunikation sendet dauerhaft (500ms, </a:t>
+            </a:r>
+            <a:r>
+              <a:rPr lang="de-DE" dirty="0" err="1"/>
+              <a:t>id</a:t>
+            </a:r>
+            <a:r>
+              <a:rPr lang="de-DE" dirty="0"/>
+              <a:t>=005, ambient </a:t>
+            </a:r>
+            <a:r>
+              <a:rPr lang="de-DE" dirty="0" err="1"/>
+              <a:t>temperature</a:t>
+            </a:r>
+            <a:r>
+              <a:rPr lang="de-DE" dirty="0"/>
+              <a:t> = 28 </a:t>
+            </a:r>
+            <a:r>
+              <a:rPr lang="de-DE" dirty="0" err="1"/>
+              <a:t>degree</a:t>
+            </a:r>
+            <a:r>
+              <a:rPr lang="de-DE" dirty="0"/>
+              <a:t>)</a:t>
+            </a:r>
+          </a:p>
+          <a:p>
+            <a:pPr lvl="2"/>
+            <a:r>
+              <a:rPr lang="de-DE" dirty="0"/>
+              <a:t>Dummy Kommunikation läuft über welchen Kanal?</a:t>
+            </a:r>
+          </a:p>
+          <a:p>
+            <a:pPr lvl="1"/>
+            <a:r>
+              <a:rPr lang="de-DE" dirty="0"/>
+              <a:t>Soll REST Server zu </a:t>
+            </a:r>
+            <a:r>
+              <a:rPr lang="de-DE" dirty="0" err="1"/>
+              <a:t>verfügung</a:t>
+            </a:r>
+            <a:r>
+              <a:rPr lang="de-DE" dirty="0"/>
+              <a:t> stellen, dort Daten publishen</a:t>
+            </a:r>
+          </a:p>
+          <a:p>
+            <a:pPr lvl="2"/>
+            <a:r>
+              <a:rPr lang="de-DE" dirty="0"/>
+              <a:t>Erstmal nur Lesen</a:t>
+            </a:r>
+          </a:p>
+          <a:p>
+            <a:pPr lvl="2"/>
+            <a:r>
+              <a:rPr lang="de-DE" dirty="0"/>
+              <a:t>Konfiguration kommt später</a:t>
+            </a:r>
+          </a:p>
+          <a:p>
+            <a:pPr lvl="1"/>
+            <a:r>
+              <a:rPr lang="de-DE" dirty="0"/>
+              <a:t>Soll Scheduling machen</a:t>
+            </a:r>
+          </a:p>
+          <a:p>
+            <a:pPr lvl="1"/>
+            <a:endParaRPr lang="de-DE" dirty="0"/>
+          </a:p>
+          <a:p>
+            <a:r>
+              <a:rPr lang="de-DE" dirty="0"/>
+              <a:t>DAS Können wir wieder </a:t>
+            </a:r>
+            <a:r>
+              <a:rPr lang="de-DE" dirty="0" err="1"/>
+              <a:t>Testdriven</a:t>
+            </a:r>
+            <a:r>
+              <a:rPr lang="de-DE" dirty="0"/>
+              <a:t> machen!</a:t>
+            </a:r>
+          </a:p>
+          <a:p>
+            <a:pPr lvl="1"/>
+            <a:r>
+              <a:rPr lang="de-DE" dirty="0"/>
+              <a:t>Hierzu brauchen wir Lokale SW-Ausführung, das ist nach dem restlichen Zeug mittlerweile ziemlich einfach.</a:t>
+            </a:r>
+          </a:p>
+        </p:txBody>
+      </p:sp>
+      <p:sp>
+        <p:nvSpPr>
+          <p:cNvPr id="4" name="Datumsplatzhalter 3">
+            <a:extLst>
+              <a:ext uri="{FF2B5EF4-FFF2-40B4-BE49-F238E27FC236}">
+                <a16:creationId xmlns:a16="http://schemas.microsoft.com/office/drawing/2014/main" id="{AAC8D4BD-E735-05EB-F77D-D020558DE7C7}"/>
+              </a:ext>
+            </a:extLst>
+          </p:cNvPr>
+          <p:cNvSpPr>
+            <a:spLocks noGrp="1"/>
+          </p:cNvSpPr>
+          <p:nvPr>
+            <p:ph type="dt" sz="half" idx="2"/>
+          </p:nvPr>
+        </p:nvSpPr>
+        <p:spPr/>
+        <p:txBody>
+          <a:bodyPr/>
+          <a:lstStyle/>
+          <a:p>
+            <a:fld id="{A4055450-52AE-4C8B-9714-2843C81CF833}" type="datetime1">
+              <a:rPr lang="de-DE" smtClean="0"/>
+              <a:t>05.09.2026</a:t>
+            </a:fld>
+            <a:endParaRPr lang="de-DE" dirty="0"/>
+          </a:p>
+        </p:txBody>
+      </p:sp>
+      <p:sp>
+        <p:nvSpPr>
+          <p:cNvPr id="5" name="Titel 4">
+            <a:extLst>
+              <a:ext uri="{FF2B5EF4-FFF2-40B4-BE49-F238E27FC236}">
+                <a16:creationId xmlns:a16="http://schemas.microsoft.com/office/drawing/2014/main" id="{A2967B5E-427C-B78E-EF52-347A2214B988}"/>
+              </a:ext>
+            </a:extLst>
+          </p:cNvPr>
+          <p:cNvSpPr>
+            <a:spLocks noGrp="1"/>
+          </p:cNvSpPr>
+          <p:nvPr>
+            <p:ph type="title"/>
+          </p:nvPr>
+        </p:nvSpPr>
+        <p:spPr/>
+        <p:txBody>
+          <a:bodyPr/>
+          <a:lstStyle/>
+          <a:p>
+            <a:r>
+              <a:rPr lang="de-DE" dirty="0"/>
+              <a:t>Nächster Meilenstein</a:t>
+            </a:r>
+          </a:p>
+        </p:txBody>
+      </p:sp>
+      <p:sp>
+        <p:nvSpPr>
+          <p:cNvPr id="6" name="Foliennummernplatzhalter 5">
+            <a:extLst>
+              <a:ext uri="{FF2B5EF4-FFF2-40B4-BE49-F238E27FC236}">
+                <a16:creationId xmlns:a16="http://schemas.microsoft.com/office/drawing/2014/main" id="{80BF7729-3B21-44CB-D0BF-19ADE772F682}"/>
+              </a:ext>
+            </a:extLst>
+          </p:cNvPr>
+          <p:cNvSpPr>
+            <a:spLocks noGrp="1"/>
+          </p:cNvSpPr>
+          <p:nvPr>
+            <p:ph type="sldNum" sz="quarter" idx="4"/>
+          </p:nvPr>
+        </p:nvSpPr>
+        <p:spPr/>
+        <p:txBody>
+          <a:bodyPr/>
+          <a:lstStyle/>
+          <a:p>
+            <a:fld id="{369A084B-84B6-4F15-B0F5-CCDC4176846B}" type="slidenum">
+              <a:rPr lang="de-DE" smtClean="0"/>
+              <a:pPr/>
+              <a:t>21</a:t>
+            </a:fld>
+            <a:endParaRPr lang="de-DE" dirty="0"/>
+          </a:p>
+        </p:txBody>
+      </p:sp>
+      <p:pic>
+        <p:nvPicPr>
+          <p:cNvPr id="8" name="Grafik 7">
+            <a:extLst>
+              <a:ext uri="{FF2B5EF4-FFF2-40B4-BE49-F238E27FC236}">
+                <a16:creationId xmlns:a16="http://schemas.microsoft.com/office/drawing/2014/main" id="{905A58BE-AE38-997E-A4AF-D3E657877C3D}"/>
+              </a:ext>
+            </a:extLst>
+          </p:cNvPr>
+          <p:cNvPicPr>
+            <a:picLocks noChangeAspect="1"/>
+          </p:cNvPicPr>
+          <p:nvPr/>
+        </p:nvPicPr>
+        <p:blipFill>
+          <a:blip r:embed="rId2"/>
+          <a:stretch>
+            <a:fillRect/>
+          </a:stretch>
+        </p:blipFill>
+        <p:spPr>
+          <a:xfrm>
+            <a:off x="2506587" y="5660566"/>
+            <a:ext cx="1762371" cy="314369"/>
+          </a:xfrm>
+          <a:prstGeom prst="rect">
+            <a:avLst/>
+          </a:prstGeom>
+        </p:spPr>
+      </p:pic>
+    </p:spTree>
+    <p:extLst>
+      <p:ext uri="{BB962C8B-B14F-4D97-AF65-F5344CB8AC3E}">
+        <p14:creationId xmlns:p14="http://schemas.microsoft.com/office/powerpoint/2010/main" val="2322296605"/>
+      </p:ext>
+    </p:extLst>
+  </p:cSld>
+  <p:clrMapOvr>
+    <a:masterClrMapping/>
+  </p:clrMapOvr>
+</p:sld>
+</file>
+
+<file path=ppt/slides/slide22.xml><?xml version="1.0" encoding="utf-8"?>
+<p:sld xmlns:a="http://schemas.openxmlformats.org/drawingml/2006/main" xmlns:r="http://schemas.openxmlformats.org/officeDocument/2006/relationships" xmlns:p="http://schemas.openxmlformats.org/presentationml/2006/main">
+  <p:cSld>
+    <p:spTree>
+      <p:nvGrpSpPr>
+        <p:cNvPr id="1" name=""/>
+        <p:cNvGrpSpPr/>
+        <p:nvPr/>
+      </p:nvGrpSpPr>
+      <p:grpSpPr>
+        <a:xfrm>
+          <a:off x="0" y="0"/>
+          <a:ext cx="0" cy="0"/>
+          <a:chOff x="0" y="0"/>
+          <a:chExt cx="0" cy="0"/>
+        </a:xfrm>
+      </p:grpSpPr>
+      <p:sp>
+        <p:nvSpPr>
+          <p:cNvPr id="2" name="Fußzeilenplatzhalter 1">
+            <a:extLst>
+              <a:ext uri="{FF2B5EF4-FFF2-40B4-BE49-F238E27FC236}">
+                <a16:creationId xmlns:a16="http://schemas.microsoft.com/office/drawing/2014/main" id="{AAF478D4-DCB1-5A8E-616A-177F5EB0B78C}"/>
+              </a:ext>
+            </a:extLst>
+          </p:cNvPr>
+          <p:cNvSpPr>
+            <a:spLocks noGrp="1"/>
+          </p:cNvSpPr>
+          <p:nvPr>
+            <p:ph type="ftr" sz="quarter" idx="3"/>
+          </p:nvPr>
+        </p:nvSpPr>
+        <p:spPr/>
+        <p:txBody>
+          <a:bodyPr/>
+          <a:lstStyle/>
+          <a:p>
+            <a:r>
+              <a:rPr lang="de-DE"/>
+              <a:t>Unternehmensmaster Smart Mechatronics</a:t>
+            </a:r>
+            <a:endParaRPr lang="de-DE" dirty="0"/>
+          </a:p>
+        </p:txBody>
+      </p:sp>
+      <p:sp>
+        <p:nvSpPr>
+          <p:cNvPr id="3" name="Inhaltsplatzhalter 2">
+            <a:extLst>
+              <a:ext uri="{FF2B5EF4-FFF2-40B4-BE49-F238E27FC236}">
+                <a16:creationId xmlns:a16="http://schemas.microsoft.com/office/drawing/2014/main" id="{D05B5255-B942-39F2-7B44-B609B77AD4ED}"/>
+              </a:ext>
+            </a:extLst>
+          </p:cNvPr>
+          <p:cNvSpPr>
+            <a:spLocks noGrp="1"/>
+          </p:cNvSpPr>
+          <p:nvPr>
+            <p:ph idx="1"/>
+          </p:nvPr>
+        </p:nvSpPr>
+        <p:spPr/>
+        <p:txBody>
+          <a:bodyPr/>
+          <a:lstStyle/>
+          <a:p>
+            <a:r>
+              <a:rPr lang="de-DE" dirty="0" err="1"/>
+              <a:t>Canbus</a:t>
+            </a:r>
+            <a:r>
+              <a:rPr lang="de-DE" dirty="0"/>
+              <a:t> </a:t>
+            </a:r>
+            <a:r>
+              <a:rPr lang="de-DE" dirty="0" err="1"/>
+              <a:t>vial</a:t>
+            </a:r>
+            <a:r>
+              <a:rPr lang="de-DE" dirty="0"/>
+              <a:t> </a:t>
+            </a:r>
+            <a:r>
+              <a:rPr lang="de-DE" dirty="0" err="1"/>
+              <a:t>simulation</a:t>
+            </a:r>
+            <a:endParaRPr lang="de-DE" dirty="0"/>
+          </a:p>
+          <a:p>
+            <a:r>
+              <a:rPr lang="de-DE" dirty="0"/>
+              <a:t>Rest: </a:t>
+            </a:r>
+            <a:r>
+              <a:rPr lang="de-DE" dirty="0" err="1"/>
+              <a:t>only</a:t>
+            </a:r>
+            <a:r>
+              <a:rPr lang="de-DE" dirty="0"/>
+              <a:t> </a:t>
+            </a:r>
+            <a:r>
+              <a:rPr lang="de-DE" dirty="0" err="1"/>
+              <a:t>read</a:t>
+            </a:r>
+            <a:r>
+              <a:rPr lang="de-DE" dirty="0"/>
+              <a:t> </a:t>
+            </a:r>
+            <a:r>
+              <a:rPr lang="de-DE" dirty="0" err="1"/>
+              <a:t>configurations</a:t>
+            </a:r>
+            <a:r>
+              <a:rPr lang="de-DE" dirty="0"/>
+              <a:t> and </a:t>
+            </a:r>
+            <a:r>
+              <a:rPr lang="de-DE" dirty="0" err="1"/>
+              <a:t>can</a:t>
+            </a:r>
+            <a:r>
+              <a:rPr lang="de-DE" dirty="0"/>
+              <a:t> </a:t>
+            </a:r>
+            <a:r>
+              <a:rPr lang="de-DE" dirty="0" err="1"/>
+              <a:t>value</a:t>
+            </a:r>
+            <a:endParaRPr lang="de-DE" dirty="0"/>
+          </a:p>
+          <a:p>
+            <a:r>
+              <a:rPr lang="de-DE" dirty="0"/>
+              <a:t>Scheduler</a:t>
+            </a:r>
+          </a:p>
+          <a:p>
+            <a:r>
+              <a:rPr lang="de-DE" dirty="0" err="1"/>
+              <a:t>Configuration</a:t>
+            </a:r>
+            <a:r>
+              <a:rPr lang="de-DE" dirty="0"/>
+              <a:t> </a:t>
+            </a:r>
+            <a:r>
+              <a:rPr lang="de-DE" dirty="0" err="1"/>
+              <a:t>reader</a:t>
+            </a:r>
+            <a:endParaRPr lang="de-DE" dirty="0"/>
+          </a:p>
+          <a:p>
+            <a:r>
+              <a:rPr lang="de-DE" dirty="0"/>
+              <a:t>Main</a:t>
+            </a:r>
+          </a:p>
+          <a:p>
+            <a:r>
+              <a:rPr lang="de-DE" dirty="0"/>
+              <a:t>Alle </a:t>
+            </a:r>
+            <a:r>
+              <a:rPr lang="de-DE" dirty="0" err="1"/>
+              <a:t>tests</a:t>
+            </a:r>
+            <a:r>
+              <a:rPr lang="de-DE" dirty="0"/>
+              <a:t> grün … Zeit fürs Review!</a:t>
+            </a:r>
+          </a:p>
+          <a:p>
+            <a:pPr lvl="1"/>
+            <a:r>
+              <a:rPr lang="de-DE" dirty="0"/>
+              <a:t>Logger muss komplettiert werden</a:t>
+            </a:r>
+          </a:p>
+          <a:p>
+            <a:pPr lvl="1"/>
+            <a:r>
+              <a:rPr lang="de-DE" dirty="0"/>
+              <a:t>CAN muss getestet werden (remote </a:t>
+            </a:r>
+            <a:r>
+              <a:rPr lang="de-DE" dirty="0" err="1"/>
+              <a:t>debugging</a:t>
+            </a:r>
+            <a:r>
+              <a:rPr lang="de-DE" dirty="0"/>
+              <a:t>)</a:t>
+            </a:r>
+          </a:p>
+          <a:p>
+            <a:pPr lvl="1"/>
+            <a:r>
+              <a:rPr lang="de-DE" dirty="0"/>
+              <a:t>Logger muss aus </a:t>
+            </a:r>
+            <a:r>
+              <a:rPr lang="de-DE"/>
+              <a:t>dem Scheduler raus</a:t>
+            </a:r>
+          </a:p>
+          <a:p>
+            <a:pPr lvl="1"/>
+            <a:endParaRPr lang="de-DE"/>
+          </a:p>
+        </p:txBody>
+      </p:sp>
+      <p:sp>
+        <p:nvSpPr>
+          <p:cNvPr id="4" name="Datumsplatzhalter 3">
+            <a:extLst>
+              <a:ext uri="{FF2B5EF4-FFF2-40B4-BE49-F238E27FC236}">
+                <a16:creationId xmlns:a16="http://schemas.microsoft.com/office/drawing/2014/main" id="{93A77C96-4A92-789E-7B75-A0DC3CDF04AC}"/>
+              </a:ext>
+            </a:extLst>
+          </p:cNvPr>
+          <p:cNvSpPr>
+            <a:spLocks noGrp="1"/>
+          </p:cNvSpPr>
+          <p:nvPr>
+            <p:ph type="dt" sz="half" idx="2"/>
+          </p:nvPr>
+        </p:nvSpPr>
+        <p:spPr/>
+        <p:txBody>
+          <a:bodyPr/>
+          <a:lstStyle/>
+          <a:p>
+            <a:fld id="{A4055450-52AE-4C8B-9714-2843C81CF833}" type="datetime1">
+              <a:rPr lang="de-DE" smtClean="0"/>
+              <a:t>05.09.2026</a:t>
+            </a:fld>
+            <a:endParaRPr lang="de-DE" dirty="0"/>
+          </a:p>
+        </p:txBody>
+      </p:sp>
+      <p:sp>
+        <p:nvSpPr>
+          <p:cNvPr id="5" name="Titel 4">
+            <a:extLst>
+              <a:ext uri="{FF2B5EF4-FFF2-40B4-BE49-F238E27FC236}">
+                <a16:creationId xmlns:a16="http://schemas.microsoft.com/office/drawing/2014/main" id="{8D8CF8AD-153E-5BDB-482B-AC3A129CE670}"/>
+              </a:ext>
+            </a:extLst>
+          </p:cNvPr>
+          <p:cNvSpPr>
+            <a:spLocks noGrp="1"/>
+          </p:cNvSpPr>
+          <p:nvPr>
+            <p:ph type="title"/>
+          </p:nvPr>
+        </p:nvSpPr>
+        <p:spPr/>
+        <p:txBody>
+          <a:bodyPr/>
+          <a:lstStyle/>
+          <a:p>
+            <a:r>
+              <a:rPr lang="de-DE" dirty="0"/>
+              <a:t>MVP</a:t>
+            </a:r>
+          </a:p>
+        </p:txBody>
+      </p:sp>
+      <p:sp>
+        <p:nvSpPr>
+          <p:cNvPr id="6" name="Foliennummernplatzhalter 5">
+            <a:extLst>
+              <a:ext uri="{FF2B5EF4-FFF2-40B4-BE49-F238E27FC236}">
+                <a16:creationId xmlns:a16="http://schemas.microsoft.com/office/drawing/2014/main" id="{71FDC844-7342-0577-D852-4A617DDCF2C4}"/>
+              </a:ext>
+            </a:extLst>
+          </p:cNvPr>
+          <p:cNvSpPr>
+            <a:spLocks noGrp="1"/>
+          </p:cNvSpPr>
+          <p:nvPr>
+            <p:ph type="sldNum" sz="quarter" idx="4"/>
+          </p:nvPr>
+        </p:nvSpPr>
+        <p:spPr/>
+        <p:txBody>
+          <a:bodyPr/>
+          <a:lstStyle/>
+          <a:p>
+            <a:fld id="{369A084B-84B6-4F15-B0F5-CCDC4176846B}" type="slidenum">
+              <a:rPr lang="de-DE" smtClean="0"/>
+              <a:pPr/>
+              <a:t>22</a:t>
+            </a:fld>
+            <a:endParaRPr lang="de-DE" dirty="0"/>
+          </a:p>
+        </p:txBody>
+      </p:sp>
+    </p:spTree>
+    <p:extLst>
+      <p:ext uri="{BB962C8B-B14F-4D97-AF65-F5344CB8AC3E}">
+        <p14:creationId xmlns:p14="http://schemas.microsoft.com/office/powerpoint/2010/main" val="3464919168"/>
       </p:ext>
     </p:extLst>
   </p:cSld>

</xml_diff>